<commit_message>
feat(nt-core): 后台进化增量 — MCP gateway 折叠规格/哈希链 + generation classifier + ADR + 能力树强化
- feat(nt-act): nt_agent_mcp_gateway — 工具规格折叠 + 证据哈希链 + 审批门控 (接线进 registry/tools)
- feat(nt-io): generation_classifier — 网关生成分类器 (接线进 GatewayV2)
- docs: architecture ADR 0001-arch-fitness-functions + 0002-panic-debt-governance
- feat(nt-core): 能力树 cli/evolution/fusion/node/registry 强化 + arch_fitness/e8_predictor 演进
- chore: telemetry/multimodal/coeffect/provenance/crawl 等后台自愈改进
- competition: GOAI 竞赛材料更新
</commit_message>
<xml_diff>
--- a/competition/goai-agent-infra/初赛方案_NeoTrix研发闭环.pptx
+++ b/competition/goai-agent-infra/初赛方案_NeoTrix研发闭环.pptx
@@ -4746,7 +4746,24 @@
                 <a:latin typeface="微软雅黑"/>
                 <a:ea typeface="微软雅黑"/>
               </a:rPr>
-              <a:t>4240 项测试 · SelfTest T1-T3 三层接线</a:t>
+              <a:t>8000+ 项测试 · SelfTest T1-T3 三层接线</a:t>
+            </a:r>
+          </a:p>
+          <a:p>
+            <a:pPr algn="l">
+              <a:lnSpc>
+                <a:spcPct val="118000"/>
+              </a:lnSpc>
+            </a:pPr>
+            <a:r>
+              <a:rPr sz="1050" b="0">
+                <a:solidFill>
+                  <a:srgbClr val="0F172A"/>
+                </a:solidFill>
+                <a:latin typeface="微软雅黑"/>
+                <a:ea typeface="微软雅黑"/>
+              </a:rPr>
+              <a:t>真实数据回归：26 家价格表 9082 行 / 3267 USD 零失败</a:t>
             </a:r>
           </a:p>
           <a:p>
@@ -6287,7 +6304,7 @@
                 <a:latin typeface="微软雅黑"/>
                 <a:ea typeface="微软雅黑"/>
               </a:rPr>
-              <a:t>4240 测试背书</a:t>
+              <a:t>8000+ 测试背书</a:t>
             </a:r>
           </a:p>
           <a:p>
@@ -7985,7 +8002,7 @@
           </a:p>
           <a:p>
             <a:r>
-              <a:t>团队成果：NeoTrix 开源项目（4240 项测试、RQGM 论文 arXiv:2606.26294）；软件研发全流程多 Agent 协同系统</a:t>
+              <a:t>团队成果：NeoTrix 开源项目（8000+ 项测试、RQGM 论文 arXiv:2606.26294）；软件研发全流程多 Agent 协同系统</a:t>
             </a:r>
           </a:p>
           <a:p>
@@ -8726,7 +8743,7 @@
                 <a:ea typeface="微软雅黑" pitchFamily="34" charset="-122"/>
                 <a:cs typeface="微软雅黑" pitchFamily="34" charset="-120"/>
               </a:rPr>
-              <a:t>① E8 确定性 64 态推理内核，根因定位可复现；② SelfTest T1-T3 生产门禁（4240 测试）+ 复盘自动结晶为 Skill。</a:t>
+              <a:t>① E8 确定性 64 态推理内核，根因定位可复现；② SelfTest T1-T3 生产门禁（8000+ 测试）+ 复盘自动结晶为 Skill。</a:t>
             </a:r>
             <a:endParaRPr lang="en-US" sz="1050" dirty="0"/>
           </a:p>
@@ -9040,7 +9057,7 @@
                 <a:ea typeface="微软雅黑" pitchFamily="34" charset="-122"/>
                 <a:cs typeface="微软雅黑" pitchFamily="34" charset="-120"/>
               </a:rPr>
-              <a:t>方案设计完成；7 域架构 23.6 万行 + 4240 测试 + MCP/Skill/KB 基础设施可支撑复赛 Demo。</a:t>
+              <a:t>方案设计完成；7 域架构 40 万行 + 8000+ 测试 + MCP/Skill/KB 基础设施可支撑复赛 Demo。</a:t>
             </a:r>
             <a:endParaRPr lang="en-US" sz="1050" dirty="0"/>
           </a:p>

</xml_diff>